<commit_message>
Remplacer « ligne de feu » par « ligne de tir » dans toute la présentation
Terminologie demandée, appliquée au deck HTML, au PPTX (régénéré) et à la
documentation (MEDIA.md, README.md). PPTX revalidé (OOXML PASSED), deck HTML
re-vérifié (Chromium).

Co-Authored-By: Claude Opus 4.8 <noreply@anthropic.com>
Claude-Session: https://claude.ai/code/session_01W6faztYTeareC4o9xRh5De
</commit_message>
<xml_diff>
--- a/presentation-sst-mains/Dhilmar-Prevention-Blessures-Mains.pptx
+++ b/presentation-sst-mains/Dhilmar-Prevention-Blessures-Mains.pptx
@@ -1626,7 +1626,7 @@
           <a:p>
             <a:r>
               <a:rPr lang="en-US" dirty="0"/>
-              <a:t>Concept central de la présentation. La « ligne de feu » (line of fire) = trajectoire d'une énergie qui peut atteindre la main. Faire nommer aux participants des exemples concrets à Éléonore. Réflexe : « si ça bouge, où va ma main ? »</a:t>
+              <a:t>Concept central de la présentation. La « ligne de tir » (line of fire) = trajectoire d'une énergie qui peut atteindre la main. Faire nommer aux participants des exemples concrets à Éléonore. Réflexe : « si ça bouge, où va ma main ? »</a:t>
             </a:r>
             <a:endParaRPr lang="en-US" dirty="0"/>
           </a:p>
@@ -1714,7 +1714,7 @@
           <a:p>
             <a:r>
               <a:rPr lang="en-US" dirty="0"/>
-              <a:t>Six familles de causes. La plupart se recoupent avec la ligne de feu. Souligner cadenassage (énergie) et le choix du gant, qui reviennent plus loin.</a:t>
+              <a:t>Six familles de causes. La plupart se recoupent avec la ligne de tir. Souligner cadenassage (énergie) et le choix du gant, qui reviennent plus loin.</a:t>
             </a:r>
             <a:endParaRPr lang="en-US" dirty="0"/>
           </a:p>
@@ -1802,7 +1802,7 @@
           <a:p>
             <a:r>
               <a:rPr lang="en-US" dirty="0"/>
-              <a:t>Diapo vidéo. Une main dans la ligne de feu : ça va vite. Insérer le clip Higgsfield (danger / ligne de feu) dans le cadre : Insertion &gt; Vidéo &gt; à partir d'un fichier, puis ajuster au cadre. Lien direct du MP4 dans MEDIA.md.</a:t>
+              <a:t>Diapo vidéo. Une main dans la ligne de tir : ça va vite. Insérer le clip Higgsfield (danger / ligne de tir) dans le cadre : Insertion &gt; Vidéo &gt; à partir d'un fichier, puis ajuster au cadre. Lien direct du MP4 dans MEDIA.md.</a:t>
             </a:r>
             <a:endParaRPr lang="en-US" dirty="0"/>
           </a:p>
@@ -3125,7 +3125,7 @@
                 <a:ea typeface="Calibri" pitchFamily="34" charset="-122"/>
                 <a:cs typeface="Calibri" pitchFamily="34" charset="-120"/>
               </a:rPr>
-              <a:t>Gardez vos mains hors de la ligne de feu.</a:t>
+              <a:t>Gardez vos mains hors de la ligne de tir.</a:t>
             </a:r>
             <a:endParaRPr lang="en-US" sz="1500" dirty="0"/>
           </a:p>
@@ -6699,7 +6699,7 @@
                 <a:ea typeface="Calibri" pitchFamily="34" charset="-122"/>
                 <a:cs typeface="Calibri" pitchFamily="34" charset="-120"/>
               </a:rPr>
-              <a:t>Mains toujours hors de la ligne de feu.</a:t>
+              <a:t>Mains toujours hors de la ligne de tir.</a:t>
             </a:r>
             <a:endParaRPr lang="en-US" sz="1350" dirty="0"/>
           </a:p>
@@ -9427,7 +9427,7 @@
                 <a:ea typeface="Calibri" pitchFamily="34" charset="-122"/>
                 <a:cs typeface="Calibri" pitchFamily="34" charset="-120"/>
               </a:rPr>
-              <a:t>Repérer la « ligne de feu » et les points de pincement.</a:t>
+              <a:t>Repérer la « ligne de tir » et les points de pincement.</a:t>
             </a:r>
             <a:endParaRPr lang="en-US" sz="1400" dirty="0"/>
           </a:p>
@@ -13008,7 +13008,7 @@
                 <a:ea typeface="Cambria" pitchFamily="34" charset="-122"/>
                 <a:cs typeface="Cambria" pitchFamily="34" charset="-120"/>
               </a:rPr>
-              <a:t>La « ligne de feu »</a:t>
+              <a:t>La « ligne de tir »</a:t>
             </a:r>
             <a:endParaRPr lang="en-US" sz="3300" dirty="0"/>
           </a:p>
@@ -15261,7 +15261,7 @@
                 <a:ea typeface="Calibri" pitchFamily="34" charset="-122"/>
                 <a:cs typeface="Calibri" pitchFamily="34" charset="-120"/>
               </a:rPr>
-              <a:t>VIDÉO — LA LIGNE DE FEU</a:t>
+              <a:t>VIDÉO — LA LIGNE DE TIR</a:t>
             </a:r>
             <a:endParaRPr lang="en-US" sz="1200" dirty="0"/>
           </a:p>
@@ -15511,7 +15511,7 @@
                 <a:ea typeface="Cambria" pitchFamily="34" charset="-122"/>
                 <a:cs typeface="Cambria" pitchFamily="34" charset="-120"/>
               </a:rPr>
-              <a:t>Une main dans la ligne de feu : ça va vite.</a:t>
+              <a:t>Une main dans la ligne de tir : ça va vite.</a:t>
             </a:r>
             <a:endParaRPr lang="en-US" sz="1800" dirty="0"/>
           </a:p>

</xml_diff>

<commit_message>
Intégrer le texte complet de la prestation dans les notes du présentateur (PPTX)
Les notes de chaque diapo contiennent désormais la narration complète, la question
d'animation et le message clé (source : script-content.js via un helper talk()),
utilisables en mode Présentateur. Rappels d'insertion de clip conservés sur les
diapos vidéo. PPTX revalidé (OOXML : PASSED).

Co-Authored-By: Claude Opus 4.8 <noreply@anthropic.com>
Claude-Session: https://claude.ai/code/session_01W6faztYTeareC4o9xRh5De
</commit_message>
<xml_diff>
--- a/presentation-sst-mains/Dhilmar-Prevention-Blessures-Mains.pptx
+++ b/presentation-sst-mains/Dhilmar-Prevention-Blessures-Mains.pptx
@@ -746,7 +746,12 @@
           <a:p>
             <a:r>
               <a:rPr lang="en-US" dirty="0"/>
-              <a:t>Ouverture. Ton : sérieux mais bienveillant. Objectif : nos mains sont notre outil no 1 et elles sont exposées chaque jour. Vidéo d'ouverture Higgsfield (tunnel) — voir MEDIA.md pour le lien. Insérer le clip sur cette diapo (glisser-déposer le MP4).</a:t>
+              <a:t>[≈ 1 min]
+Bonjour à tous, et merci d'être là. On prend une quinzaine de minutes ensemble sur un sujet qui nous concerne tous, peu importe le métier : nos mains.
+On les utilise à chaque geste, à chaque quart — et pourtant, c'est une des parties du corps qu'on blesse le plus souvent. L'objectif aujourd'hui, ce n'est pas de vous faire peur : c'est de repartir avec des réflexes simples pour que tout le monde rentre à la maison avec ses deux mains, en pleine forme.
+DEMANDEZ : Levez la main : qui, ici, utilise ses mains comme principal outil de travail ? — Exactement, tout le monde.
+À RETENIR : Le sujet nous concerne tous, chaque jour.
+— Clip : vidéo d'ouverture Higgsfield (tunnel). Glisser le MP4 sur la diapo — voir MEDIA.md.</a:t>
             </a:r>
             <a:endParaRPr lang="en-US" dirty="0"/>
           </a:p>
@@ -834,7 +839,11 @@
           <a:p>
             <a:r>
               <a:rPr lang="en-US" dirty="0"/>
-              <a:t>Checklist des réflexes. Insister sur le cadenassage et le fait de ne jamais retirer un gant près d'une rotation (risque d'entraînement). La règle d'or : le droit et le devoir d'arrêter le travail.</a:t>
+              <a:t>[≈ 2 min]
+Concrètement, au quotidien, voici les réflexes. Gardez vos mains hors de la ligne de tir. Cadenassez et déchargez l'énergie avant d'intervenir — toujours. Utilisez des poussoirs, des crochets, des outils — jamais vos doigts pour dégager ou guider. Inspectez vos gants et changez-les dès qu'ils sont usés ou troués. Ne retirez jamais un gant près d'une pièce en rotation : le gant peut être happé et entraîner votre main. Et signalez les points de pincement pour qu'on les neutralise.
+Et la règle d'or, celle à retenir par-dessus tout : si vous ne voyez pas vos mains en sécurité, vous arrêtez. Aucune tâche n'est urgente au point de risquer une main. Vous avez tous le droit — et le devoir — d'arrêter le travail.
+DEMANDEZ : Est-ce que tout le monde est à l'aise avec le droit d'arrêt de travail ?
+À RETENIR : Si tu ne vois pas tes mains en sécurité — ARRÊTE.</a:t>
             </a:r>
             <a:endParaRPr lang="en-US" dirty="0"/>
           </a:p>
@@ -922,7 +931,11 @@
           <a:p>
             <a:r>
               <a:rPr lang="en-US" dirty="0"/>
-              <a:t>Tableau de sélection. Rappeler qu'un gant anti-coupure NE protège PAS contre les pièces en rotation (risque d'entraînement). Adapter le gant à la tâche. Source : ASP Mines, normes EN 388 / EN 374 / EN ISO 10819 / EN 511.</a:t>
+              <a:t>[≈ 2 min]
+Le bon gant, c'est celui qui correspond au risque ET à la tâche. Rapidement : pour la manutention et les arêtes vives, un gant anti-coupure, niveau EN 388 C à F. Pour les travaux lourds et l'abrasion, du cuir ou un gant renforcé. Pour les huiles, hydrocarbures et produits chimiques, un gant nitrile ou néoprène étanche. Pour les outils vibrants, un gant anti-vibration. Pour le froid l'hiver, un gant isolé. Et pour les travaux électriques, un gant isolant diélectrique.
+Un point crucial : un gant anti-coupure ne protège PAS contre une pièce en rotation — au contraire, il peut être entraîné. Le bon gant, au bon endroit. Et un gant usé ou troué ne protège plus : inspectez-le avant chaque quart. [Faire circuler les gants]
+DEMANDEZ : Est-ce que vous avez toujours accès facilement au bon gant pour vos tâches ?
+À RETENIR : Le bon gant = le risque + la tâche.</a:t>
             </a:r>
             <a:endParaRPr lang="en-US" dirty="0"/>
           </a:p>
@@ -1010,7 +1023,12 @@
           <a:p>
             <a:r>
               <a:rPr lang="en-US" dirty="0"/>
-              <a:t>Diapo vidéo. Mains protégées, contrôlées, dégagées. Insérer le clip Higgsfield (bonne méthode / gants) dans le cadre : Insertion &gt; Vidéo &gt; à partir d'un fichier, puis ajuster au cadre. Lien direct du MP4 dans MEDIA.md.</a:t>
+              <a:t>[≈ 1 min]
+[Avant de lancer] À l'inverse, voici à quoi ça ressemble quand c'est bien fait. Observez : le gant est adapté et en bon état, la prise est ferme et contrôlée, et les mains restent hors de la ligne de tir.
+[Lancer la vidéo — 5 s]
+[Après] Voilà. Rien de spectaculaire — et c'est justement le but. Le travail sécuritaire, c'est ça : contrôlé, dégagé, sans surprise.
+À RETENIR : Protégé, contrôlé, dégagé.
+— Clip : insérer la vidéo Higgsfield (bonne méthode / gants) dans le cadre (Insertion &gt; Vidéo &gt; à partir d'un fichier). Lien MP4 dans MEDIA.md.</a:t>
             </a:r>
             <a:endParaRPr lang="en-US" dirty="0"/>
           </a:p>
@@ -1098,7 +1116,11 @@
           <a:p>
             <a:r>
               <a:rPr lang="en-US" dirty="0"/>
-              <a:t>Processus en 4 étapes. Message anti-sous-déclaration : déclarer une égratignure ou un « presqu'accident » permet de corriger avant l'accident grave. Rappeler les numéros/infirmerie du site.</a:t>
+              <a:t>[≈ 1,5 min]
+Malgré tout, si une blessure arrive, voici les quatre étapes. Un : arrêter et sécuriser — on stoppe la tâche, on neutralise l'énergie, on protège la zone. Deux : les premiers soins immédiatement — secouriste ou infirmerie. Trois : signaler tout de suite au superviseur. Quatre, celui qu'on oublie trop souvent : déclarer — même une simple égratignure, même un presqu'accident.
+Pourquoi ? Parce qu'un petit incident déclaré aujourd'hui, c'est ce qui nous permet de corriger avant l'accident grave de demain. Déclarer, ce n'est jamais une faute — c'est une force pour toute l'équipe.
+DEMANDEZ : Est-ce que tout le monde sait où est l'infirmerie et qui sont les secouristes de son quart ?
+À RETENIR : Déclarer, même une égratignure.</a:t>
             </a:r>
             <a:endParaRPr lang="en-US" dirty="0"/>
           </a:p>
@@ -1186,7 +1208,12 @@
           <a:p>
             <a:r>
               <a:rPr lang="en-US" dirty="0"/>
-              <a:t>Clôture. Rappeler l'engagement collectif et le droit d'arrêt de travail. Vidéo de clôture Higgsfield (équipe, lever de soleil) — voir MEDIA.md. Ouvrir la discussion.</a:t>
+              <a:t>[≈ 1 min]
+On termine là-dessus. Chez Dhilmar, à Éléonore, on veut une chose toute simple : que chacun rentre à la maison avec ses deux mains, en pleine forme.
+Ça passe par les réflexes qu'on a vus aujourd'hui — voir la ligne de tir, garder les mains dégagées, porter le bon gant, et arrêter quand il le faut. La sécurité des mains, c'est l'affaire de chacun, à chaque quart, à chaque geste. Merci de votre attention et de votre engagement. Je prends vos questions.
+DEMANDEZ : Ouvrir la discussion — questions et échanges.
+À RETENIR : On rentre tous à la maison avec nos deux mains.
+— Clip : vidéo de clôture Higgsfield (équipe, lever de soleil). Glisser sur la diapo — voir MEDIA.md.</a:t>
             </a:r>
             <a:endParaRPr lang="en-US" dirty="0"/>
           </a:p>
@@ -1274,7 +1301,10 @@
           <a:p>
             <a:r>
               <a:rPr lang="en-US" dirty="0"/>
-              <a:t>Cadrer la rencontre. 4 objectifs. Insister : la sécurité des mains n'est pas une contrainte, c'est un réflexe qui protège toute une carrière.</a:t>
+              <a:t>[≈ 1 min]
+Voici notre plan, quatre choses simples. Un : comprendre pourquoi nos mains sont autant exposées dans nos opérations. Deux : reconnaître ce qu'on appelle la « ligne de tir ». Trois : choisir et porter le bon gant selon la tâche. Quatre : savoir quoi faire — et déclarer — si ça arrive.
+TRANSITION : Commençons par ce qu'on protège.
+À RETENIR : Un objectif clair : des réflexes concrets, pas de la théorie.</a:t>
             </a:r>
             <a:endParaRPr lang="en-US" dirty="0"/>
           </a:p>
@@ -1362,7 +1392,11 @@
           <a:p>
             <a:r>
               <a:rPr lang="en-US" dirty="0"/>
-              <a:t>Accroche émotionnelle. Faire lever la main : « qui utilise ses mains toute la journée ? ». 27 os par main. Aucune pièce de rechange. Source : anatomie humaine; OSHA/BLS pour le 1 M+.</a:t>
+              <a:t>[≈ 1,5 min]
+Prenez une seconde, regardez vos mains. Il y a 27 os dans chacune — plus du quart des os de tout votre corps, concentrés dans un tout petit espace. Ajoutez les tendons, les nerfs, les vaisseaux : c'est un outil d'une précision incroyable.
+Mais contrairement à une clé ou à un boulon, il n'y a pas de pièce de rechange. Une lacération profonde, un doigt écrasé, et c'est parfois une perte de mobilité pour la vie. Aux États-Unis seulement, plus d'un million de travailleurs se présentent à l'urgence chaque année pour une blessure à la main.
+DEMANDEZ : Est-ce que quelqu'un connaît une personne qui a gardé des séquelles à une main après un accident ?
+À RETENIR : Irremplaçables : aucune pièce de rechange.</a:t>
             </a:r>
             <a:endParaRPr lang="en-US" dirty="0"/>
           </a:p>
@@ -1450,7 +1484,12 @@
           <a:p>
             <a:r>
               <a:rPr lang="en-US" dirty="0"/>
-              <a:t>Marteler les chiffres. Le 70 % (aucun gant) et le 71 % (évitable) sont le cœur du message : la très grande majorité de ces blessures sont évitables. Sources indiquées sur chaque carte : NSC, OSHA, CNESST, NIOSH.</a:t>
+              <a:t>[≈ 2 min]
+Regardons les chiffres, parce qu'ils sont parlants. Premièrement : environ 70 % des blessures aux mains arrivent à des gens qui ne portaient aucun gant. Et le 30 % qui restait ? Ils avaient un gant — mais pas le bon pour la tâche.
+Deuxièmement, et c'est la bonne nouvelle : 71 % de ces blessures pourraient être évitées avec le bon équipement. Autrement dit, la très grande majorité de ce qu'on voit aujourd'hui est évitable.
+Au Québec, environ 15 % de toutes les lésions indemnisées touchent les poignets, les mains et les doigts. Et quand il y a perte de temps, plus de 60 % de ces blessures sont des fractures ou des amputations.
+DEMANDEZ : À votre avis, sur dix blessures aux mains, combien arrivent sans gant ? (Réponse : environ sept.)
+À RETENIR : 70 % sans gant · 71 % évitables.</a:t>
             </a:r>
             <a:endParaRPr lang="en-US" dirty="0"/>
           </a:p>
@@ -1538,7 +1577,12 @@
           <a:p>
             <a:r>
               <a:rPr lang="en-US" dirty="0"/>
-              <a:t>Les lacérations (53 %) et fractures (26 %) dominent. Le coût médian (13 700–16 200 $) parle aux gestionnaires ET rappelle l'impact humain. Vibrations : enjeu réel avec la foreuse et les outils — gants anti-vibration + rotation des tâches. Sources : MSHA/NIOSH, IRSST.</a:t>
+              <a:t>[≈ 2 min]
+Dans le secteur minier précisément, voici le portrait. Les blessures les plus fréquentes aux mains, ce sont les lacérations — plus de la moitié — suivies des fractures, environ le quart.
+Côté coûts, une blessure à la main avec perte de temps, c'est en moyenne entre 13 700 et 16 200 dollars de coûts directs — sans parler de la douleur et de l'impact sur la personne et sur l'équipe.
+Et un enjeu bien à nous : les vibrations. Avec des outils comme la foreuse, on parle du syndrome des doigts blancs — près des deux tiers des travailleurs affectés rapportent des engourdissements, un tiers, des douleurs articulaires. C'est insidieux : ça s'installe avec le temps.
+DEMANDEZ : Qui utilise régulièrement des outils qui vibrent — foreuse, marteau, meuleuse ?
+À RETENIR : Lacérations et fractures dominent; les vibrations sont un enjeu réel.</a:t>
             </a:r>
             <a:endParaRPr lang="en-US" dirty="0"/>
           </a:p>
@@ -1626,7 +1670,11 @@
           <a:p>
             <a:r>
               <a:rPr lang="en-US" dirty="0"/>
-              <a:t>Concept central de la présentation. La « ligne de tir » (line of fire) = trajectoire d'une énergie qui peut atteindre la main. Faire nommer aux participants des exemples concrets à Éléonore. Réflexe : « si ça bouge, où va ma main ? »</a:t>
+              <a:t>[≈ 2 min]
+Voici le concept le plus important de la rencontre : la « ligne de tir ». C'est toute zone où votre main peut être happée, écrasée, coupée ou pincée par une énergie — mécanique, hydraulique, électrique, ou simplement la gravité.
+Sur le schéma, la main est au centre, et tout autour, les dangers : écrasement, coupure, happement, pincement. Le réflexe à développer, avant chaque geste, tient en une question : « Si cette pièce bouge, où va ma main ? » Si la réponse, c'est « dans la zone de danger », on se replace.
+DEMANDEZ : Donnez-moi un exemple concret de point de pincement que vous croisez ici, à Éléonore.
+À RETENIR : « Si ça bouge, où va ma main ? »</a:t>
             </a:r>
             <a:endParaRPr lang="en-US" dirty="0"/>
           </a:p>
@@ -1714,7 +1762,11 @@
           <a:p>
             <a:r>
               <a:rPr lang="en-US" dirty="0"/>
-              <a:t>Six familles de causes. La plupart se recoupent avec la ligne de tir. Souligner cadenassage (énergie) et le choix du gant, qui reviennent plus loin.</a:t>
+              <a:t>[≈ 1,5 min]
+D'où viennent concrètement les blessures ? Six grandes familles. Les points de pincement et de happement — pièces mobiles, engrenages, convoyeurs. Les outils et les lames — couteaux, meuleuses. La manutention et les arêtes vives — tôle, charges lourdes.
+L'énergie non maîtrisée — quand on n'a pas cadenassé. Les vibrations, dont on vient de parler. Et enfin, le gant absent ou inadéquat. Vous remarquez que presque toutes se ramènent à la ligne de tir.
+TRANSITION : Voyons ce que ça donne en vrai.
+À RETENIR : Presque toutes les causes ramènent à la ligne de tir.</a:t>
             </a:r>
             <a:endParaRPr lang="en-US" dirty="0"/>
           </a:p>
@@ -1802,7 +1854,13 @@
           <a:p>
             <a:r>
               <a:rPr lang="en-US" dirty="0"/>
-              <a:t>Diapo vidéo. Une main dans la ligne de tir : ça va vite. Insérer le clip Higgsfield (danger / ligne de tir) dans le cadre : Insertion &gt; Vidéo &gt; à partir d'un fichier, puis ajuster au cadre. Lien direct du MP4 dans MEDIA.md.</a:t>
+              <a:t>[≈ 1,5 min]
+[Avant de lancer] Regardez bien cette courte séquence. Observez trois choses : où sont les mains par rapport aux pièces mobiles, si le point de pincement était visible, et ce qui aurait pu éliminer le risque.
+[Lancer la vidéo — 5 s, à rejouer au besoin]
+[Après] Ça va vite, hein ? Une fraction de seconde. La main était dans la ligne de tir. C'est exactement le genre de situation qu'on veut apprendre à voir venir.
+DEMANDEZ : Qu'est-ce que vous auriez fait différemment ?
+À RETENIR : Ça va vite : il faut anticiper.
+— Clip : insérer la vidéo Higgsfield (danger / ligne de tir) dans le cadre (Insertion &gt; Vidéo &gt; à partir d'un fichier). Lien MP4 dans MEDIA.md.</a:t>
             </a:r>
             <a:endParaRPr lang="en-US" dirty="0"/>
           </a:p>
@@ -1890,7 +1948,10 @@
           <a:p>
             <a:r>
               <a:rPr lang="en-US" dirty="0"/>
-              <a:t>Message clé de culture SST : le gant est en BAS de la hiérarchie. On élimine et on protège la source AVANT de compter sur l'ÉPI. Le gant reste essentiel comme dernière barrière.</a:t>
+              <a:t>[≈ 2 min]
+Maintenant, comment on se protège — dans le bon ordre. C'est la hiérarchie des moyens de prévention. En haut, le plus efficace : éliminer le danger complètement. Ensuite, le substituer ou réduire l'énergie en jeu. Puis l'ingénierie : protecteurs, gardes, outils qui gardent la main à distance. Ensuite l'administratif : procédures, cadenassage, formation. Et tout en bas : l'équipement de protection — le gant.
+Message important : le gant, c'est la dernière barrière, jamais la première. Il est essentiel, mais il ne remplace pas un protecteur ou un cadenassage. On ne compte pas sur le gant pour faire le travail qu'un garde devrait faire.
+À RETENIR : Le gant est la dernière barrière, pas la première.</a:t>
             </a:r>
             <a:endParaRPr lang="en-US" dirty="0"/>
           </a:p>

</xml_diff>